<commit_message>
Grid cycle (slide 6 + comp plan): add Direct (30%) + Uni-level (6.25%) columns
'One Full Grid Cycle' previously showed only the completion bonus. Now shows
all three Grid income types per tier:
- Direct (30%): $6 -> $300 (exact, per activation)
- Uni-level (6.25%): $1.25 -> $62.50 PER POSITION (earned on every position
  through 8 levels, not a per-tier total -- labelled as such to avoid overstating)
- Completion bonus (20%): $64 -> $3,200 (kept as the gold highlight column)

Surfaces:
- EN deck (static/downloads/income-streams/...-EN.pptx) rebuilt to 5-col table
- /compensation-plan: 5-col table, scroll-wrapped for mobile, + per-position note

Numbers reconciled to commission-spec (DIRECT_PCT=0.30, PER_LEVEL_PCT=0.0625,
BONUS_POOL_PCT=0.20, 16 seats). DE deck regenerated separately (not yet wired).
</commit_message>
<xml_diff>
--- a/static/downloads/income-streams/SuperAdPro-3-Income-Streams-EN.pptx
+++ b/static/downloads/income-streams/SuperAdPro-3-Income-Streams-EN.pptx
@@ -7889,6 +7889,10 @@
           </a:solidFill>
           <a:ln/>
         </p:spPr>
+        <p:txBody>
+          <a:bodyPr/>
+          <a:p/>
+        </p:txBody>
       </p:sp>
       <p:sp>
         <p:nvSpPr>
@@ -8079,6 +8083,10 @@
           </a:solidFill>
           <a:ln/>
         </p:spPr>
+        <p:txBody>
+          <a:bodyPr/>
+          <a:p/>
+        </p:txBody>
       </p:sp>
       <p:sp>
         <p:nvSpPr>
@@ -8127,24 +8135,24 @@
         </p:nvSpPr>
         <p:spPr>
           <a:xfrm>
-            <a:off x="4155034" y="1938528"/>
-            <a:ext cx="1528877" cy="310896"/>
-          </a:xfrm>
-          <a:prstGeom prst="rect">
-            <a:avLst/>
-          </a:prstGeom>
-          <a:noFill/>
-          <a:ln/>
-        </p:spPr>
-        <p:txBody>
-          <a:bodyPr wrap="square" lIns="0" tIns="0" rIns="0" bIns="0" rtlCol="0" anchor="ctr"/>
-          <a:lstStyle/>
-          <a:p>
-            <a:pPr algn="ctr" indent="0" marL="0">
-              <a:buNone/>
-            </a:pPr>
-            <a:r>
-              <a:rPr lang="en-US" sz="1000" b="1" spc="100" kern="0" dirty="0">
+            <a:off x="2697480" y="1938528"/>
+            <a:ext cx="1143000" cy="310896"/>
+          </a:xfrm>
+          <a:prstGeom prst="rect">
+            <a:avLst/>
+          </a:prstGeom>
+          <a:noFill/>
+          <a:ln/>
+        </p:spPr>
+        <p:txBody>
+          <a:bodyPr wrap="square" lIns="0" tIns="0" rIns="0" bIns="0" rtlCol="0" anchor="ctr"/>
+          <a:lstStyle/>
+          <a:p>
+            <a:pPr algn="ctr" indent="0" marL="0">
+              <a:buNone/>
+            </a:pPr>
+            <a:r>
+              <a:rPr lang="en-US" sz="800" b="1" spc="100" kern="0" dirty="0">
                 <a:solidFill>
                   <a:srgbClr val="22D3EE"/>
                 </a:solidFill>
@@ -8152,7 +8160,7 @@
                 <a:ea typeface="Arial" pitchFamily="34" charset="-122"/>
                 <a:cs typeface="Arial" pitchFamily="34" charset="-120"/>
               </a:rPr>
-              <a:t>TIER PRICE</a:t>
+              <a:t>PRICE</a:t>
             </a:r>
             <a:endParaRPr lang="en-US" sz="1000" dirty="0"/>
           </a:p>
@@ -8166,24 +8174,24 @@
         </p:nvSpPr>
         <p:spPr>
           <a:xfrm>
-            <a:off x="5866790" y="1938528"/>
-            <a:ext cx="1923898" cy="310896"/>
-          </a:xfrm>
-          <a:prstGeom prst="rect">
-            <a:avLst/>
-          </a:prstGeom>
-          <a:noFill/>
-          <a:ln/>
-        </p:spPr>
-        <p:txBody>
-          <a:bodyPr wrap="square" lIns="0" tIns="0" rIns="0" bIns="0" rtlCol="0" anchor="ctr"/>
-          <a:lstStyle/>
-          <a:p>
-            <a:pPr algn="r" indent="0" marL="0">
-              <a:buNone/>
-            </a:pPr>
-            <a:r>
-              <a:rPr lang="en-US" sz="1000" b="1" spc="100" kern="0" dirty="0">
+            <a:off x="6355080" y="1938528"/>
+            <a:ext cx="1417320" cy="310896"/>
+          </a:xfrm>
+          <a:prstGeom prst="rect">
+            <a:avLst/>
+          </a:prstGeom>
+          <a:noFill/>
+          <a:ln/>
+        </p:spPr>
+        <p:txBody>
+          <a:bodyPr wrap="square" lIns="0" tIns="0" rIns="0" bIns="0" rtlCol="0" anchor="ctr"/>
+          <a:lstStyle/>
+          <a:p>
+            <a:pPr algn="ctr" indent="0" marL="0">
+              <a:buNone/>
+            </a:pPr>
+            <a:r>
+              <a:rPr lang="en-US" sz="800" b="1" spc="100" kern="0" dirty="0">
                 <a:solidFill>
                   <a:srgbClr val="22D3EE"/>
                 </a:solidFill>
@@ -8191,7 +8199,7 @@
                 <a:ea typeface="Arial" pitchFamily="34" charset="-122"/>
                 <a:cs typeface="Arial" pitchFamily="34" charset="-120"/>
               </a:rPr>
-              <a:t>COMPLETION BONUS (20%)</a:t>
+              <a:t>COMPLETION (20%)</a:t>
             </a:r>
             <a:endParaRPr lang="en-US" sz="1000" dirty="0"/>
           </a:p>
@@ -8216,6 +8224,10 @@
           </a:solidFill>
           <a:ln/>
         </p:spPr>
+        <p:txBody>
+          <a:bodyPr/>
+          <a:p/>
+        </p:txBody>
       </p:sp>
       <p:sp>
         <p:nvSpPr>
@@ -8264,8 +8276,8 @@
         </p:nvSpPr>
         <p:spPr>
           <a:xfrm>
-            <a:off x="4045306" y="2249424"/>
-            <a:ext cx="1711757" cy="283464"/>
+            <a:off x="2697480" y="2249424"/>
+            <a:ext cx="1143000" cy="283464"/>
           </a:xfrm>
           <a:prstGeom prst="rect">
             <a:avLst/>
@@ -8303,20 +8315,20 @@
         </p:nvSpPr>
         <p:spPr>
           <a:xfrm>
-            <a:off x="5757062" y="2249424"/>
-            <a:ext cx="1978762" cy="283464"/>
-          </a:xfrm>
-          <a:prstGeom prst="rect">
-            <a:avLst/>
-          </a:prstGeom>
-          <a:noFill/>
-          <a:ln/>
-        </p:spPr>
-        <p:txBody>
-          <a:bodyPr wrap="square" lIns="0" tIns="0" rIns="0" bIns="0" rtlCol="0" anchor="ctr"/>
-          <a:lstStyle/>
-          <a:p>
-            <a:pPr algn="r" indent="0" marL="0">
+            <a:off x="6355080" y="2249424"/>
+            <a:ext cx="1417320" cy="283464"/>
+          </a:xfrm>
+          <a:prstGeom prst="rect">
+            <a:avLst/>
+          </a:prstGeom>
+          <a:noFill/>
+          <a:ln/>
+        </p:spPr>
+        <p:txBody>
+          <a:bodyPr wrap="square" lIns="0" tIns="0" rIns="0" bIns="0" rtlCol="0" anchor="ctr"/>
+          <a:lstStyle/>
+          <a:p>
+            <a:pPr algn="ctr" indent="0" marL="0">
               <a:buNone/>
             </a:pPr>
             <a:r>
@@ -8353,6 +8365,10 @@
           </a:solidFill>
           <a:ln/>
         </p:spPr>
+        <p:txBody>
+          <a:bodyPr/>
+          <a:p/>
+        </p:txBody>
       </p:sp>
       <p:sp>
         <p:nvSpPr>
@@ -8401,8 +8417,8 @@
         </p:nvSpPr>
         <p:spPr>
           <a:xfrm>
-            <a:off x="4045306" y="2532888"/>
-            <a:ext cx="1711757" cy="283464"/>
+            <a:off x="2697480" y="2532888"/>
+            <a:ext cx="1143000" cy="283464"/>
           </a:xfrm>
           <a:prstGeom prst="rect">
             <a:avLst/>
@@ -8440,20 +8456,20 @@
         </p:nvSpPr>
         <p:spPr>
           <a:xfrm>
-            <a:off x="5757062" y="2532888"/>
-            <a:ext cx="1978762" cy="283464"/>
-          </a:xfrm>
-          <a:prstGeom prst="rect">
-            <a:avLst/>
-          </a:prstGeom>
-          <a:noFill/>
-          <a:ln/>
-        </p:spPr>
-        <p:txBody>
-          <a:bodyPr wrap="square" lIns="0" tIns="0" rIns="0" bIns="0" rtlCol="0" anchor="ctr"/>
-          <a:lstStyle/>
-          <a:p>
-            <a:pPr algn="r" indent="0" marL="0">
+            <a:off x="6355080" y="2532888"/>
+            <a:ext cx="1417320" cy="283464"/>
+          </a:xfrm>
+          <a:prstGeom prst="rect">
+            <a:avLst/>
+          </a:prstGeom>
+          <a:noFill/>
+          <a:ln/>
+        </p:spPr>
+        <p:txBody>
+          <a:bodyPr wrap="square" lIns="0" tIns="0" rIns="0" bIns="0" rtlCol="0" anchor="ctr"/>
+          <a:lstStyle/>
+          <a:p>
+            <a:pPr algn="ctr" indent="0" marL="0">
               <a:buNone/>
             </a:pPr>
             <a:r>
@@ -8490,6 +8506,10 @@
           </a:solidFill>
           <a:ln/>
         </p:spPr>
+        <p:txBody>
+          <a:bodyPr/>
+          <a:p/>
+        </p:txBody>
       </p:sp>
       <p:sp>
         <p:nvSpPr>
@@ -8538,8 +8558,8 @@
         </p:nvSpPr>
         <p:spPr>
           <a:xfrm>
-            <a:off x="4045306" y="2816352"/>
-            <a:ext cx="1711757" cy="283464"/>
+            <a:off x="2697480" y="2816352"/>
+            <a:ext cx="1143000" cy="283464"/>
           </a:xfrm>
           <a:prstGeom prst="rect">
             <a:avLst/>
@@ -8577,20 +8597,20 @@
         </p:nvSpPr>
         <p:spPr>
           <a:xfrm>
-            <a:off x="5757062" y="2816352"/>
-            <a:ext cx="1978762" cy="283464"/>
-          </a:xfrm>
-          <a:prstGeom prst="rect">
-            <a:avLst/>
-          </a:prstGeom>
-          <a:noFill/>
-          <a:ln/>
-        </p:spPr>
-        <p:txBody>
-          <a:bodyPr wrap="square" lIns="0" tIns="0" rIns="0" bIns="0" rtlCol="0" anchor="ctr"/>
-          <a:lstStyle/>
-          <a:p>
-            <a:pPr algn="r" indent="0" marL="0">
+            <a:off x="6355080" y="2816352"/>
+            <a:ext cx="1417320" cy="283464"/>
+          </a:xfrm>
+          <a:prstGeom prst="rect">
+            <a:avLst/>
+          </a:prstGeom>
+          <a:noFill/>
+          <a:ln/>
+        </p:spPr>
+        <p:txBody>
+          <a:bodyPr wrap="square" lIns="0" tIns="0" rIns="0" bIns="0" rtlCol="0" anchor="ctr"/>
+          <a:lstStyle/>
+          <a:p>
+            <a:pPr algn="ctr" indent="0" marL="0">
               <a:buNone/>
             </a:pPr>
             <a:r>
@@ -8627,6 +8647,10 @@
           </a:solidFill>
           <a:ln/>
         </p:spPr>
+        <p:txBody>
+          <a:bodyPr/>
+          <a:p/>
+        </p:txBody>
       </p:sp>
       <p:sp>
         <p:nvSpPr>
@@ -8675,8 +8699,8 @@
         </p:nvSpPr>
         <p:spPr>
           <a:xfrm>
-            <a:off x="4045306" y="3099816"/>
-            <a:ext cx="1711757" cy="283464"/>
+            <a:off x="2697480" y="3099816"/>
+            <a:ext cx="1143000" cy="283464"/>
           </a:xfrm>
           <a:prstGeom prst="rect">
             <a:avLst/>
@@ -8714,20 +8738,20 @@
         </p:nvSpPr>
         <p:spPr>
           <a:xfrm>
-            <a:off x="5757062" y="3099816"/>
-            <a:ext cx="1978762" cy="283464"/>
-          </a:xfrm>
-          <a:prstGeom prst="rect">
-            <a:avLst/>
-          </a:prstGeom>
-          <a:noFill/>
-          <a:ln/>
-        </p:spPr>
-        <p:txBody>
-          <a:bodyPr wrap="square" lIns="0" tIns="0" rIns="0" bIns="0" rtlCol="0" anchor="ctr"/>
-          <a:lstStyle/>
-          <a:p>
-            <a:pPr algn="r" indent="0" marL="0">
+            <a:off x="6355080" y="3099816"/>
+            <a:ext cx="1417320" cy="283464"/>
+          </a:xfrm>
+          <a:prstGeom prst="rect">
+            <a:avLst/>
+          </a:prstGeom>
+          <a:noFill/>
+          <a:ln/>
+        </p:spPr>
+        <p:txBody>
+          <a:bodyPr wrap="square" lIns="0" tIns="0" rIns="0" bIns="0" rtlCol="0" anchor="ctr"/>
+          <a:lstStyle/>
+          <a:p>
+            <a:pPr algn="ctr" indent="0" marL="0">
               <a:buNone/>
             </a:pPr>
             <a:r>
@@ -8764,6 +8788,10 @@
           </a:solidFill>
           <a:ln/>
         </p:spPr>
+        <p:txBody>
+          <a:bodyPr/>
+          <a:p/>
+        </p:txBody>
       </p:sp>
       <p:sp>
         <p:nvSpPr>
@@ -8812,8 +8840,8 @@
         </p:nvSpPr>
         <p:spPr>
           <a:xfrm>
-            <a:off x="4045306" y="3383280"/>
-            <a:ext cx="1711757" cy="283464"/>
+            <a:off x="2697480" y="3383280"/>
+            <a:ext cx="1143000" cy="283464"/>
           </a:xfrm>
           <a:prstGeom prst="rect">
             <a:avLst/>
@@ -8851,20 +8879,20 @@
         </p:nvSpPr>
         <p:spPr>
           <a:xfrm>
-            <a:off x="5757062" y="3383280"/>
-            <a:ext cx="1978762" cy="283464"/>
-          </a:xfrm>
-          <a:prstGeom prst="rect">
-            <a:avLst/>
-          </a:prstGeom>
-          <a:noFill/>
-          <a:ln/>
-        </p:spPr>
-        <p:txBody>
-          <a:bodyPr wrap="square" lIns="0" tIns="0" rIns="0" bIns="0" rtlCol="0" anchor="ctr"/>
-          <a:lstStyle/>
-          <a:p>
-            <a:pPr algn="r" indent="0" marL="0">
+            <a:off x="6355080" y="3383280"/>
+            <a:ext cx="1417320" cy="283464"/>
+          </a:xfrm>
+          <a:prstGeom prst="rect">
+            <a:avLst/>
+          </a:prstGeom>
+          <a:noFill/>
+          <a:ln/>
+        </p:spPr>
+        <p:txBody>
+          <a:bodyPr wrap="square" lIns="0" tIns="0" rIns="0" bIns="0" rtlCol="0" anchor="ctr"/>
+          <a:lstStyle/>
+          <a:p>
+            <a:pPr algn="ctr" indent="0" marL="0">
               <a:buNone/>
             </a:pPr>
             <a:r>
@@ -8901,6 +8929,10 @@
           </a:solidFill>
           <a:ln/>
         </p:spPr>
+        <p:txBody>
+          <a:bodyPr/>
+          <a:p/>
+        </p:txBody>
       </p:sp>
       <p:sp>
         <p:nvSpPr>
@@ -8949,8 +8981,8 @@
         </p:nvSpPr>
         <p:spPr>
           <a:xfrm>
-            <a:off x="4045306" y="3666744"/>
-            <a:ext cx="1711757" cy="283464"/>
+            <a:off x="2697480" y="3666744"/>
+            <a:ext cx="1143000" cy="283464"/>
           </a:xfrm>
           <a:prstGeom prst="rect">
             <a:avLst/>
@@ -8988,20 +9020,20 @@
         </p:nvSpPr>
         <p:spPr>
           <a:xfrm>
-            <a:off x="5757062" y="3666744"/>
-            <a:ext cx="1978762" cy="283464"/>
-          </a:xfrm>
-          <a:prstGeom prst="rect">
-            <a:avLst/>
-          </a:prstGeom>
-          <a:noFill/>
-          <a:ln/>
-        </p:spPr>
-        <p:txBody>
-          <a:bodyPr wrap="square" lIns="0" tIns="0" rIns="0" bIns="0" rtlCol="0" anchor="ctr"/>
-          <a:lstStyle/>
-          <a:p>
-            <a:pPr algn="r" indent="0" marL="0">
+            <a:off x="6355080" y="3666744"/>
+            <a:ext cx="1417320" cy="283464"/>
+          </a:xfrm>
+          <a:prstGeom prst="rect">
+            <a:avLst/>
+          </a:prstGeom>
+          <a:noFill/>
+          <a:ln/>
+        </p:spPr>
+        <p:txBody>
+          <a:bodyPr wrap="square" lIns="0" tIns="0" rIns="0" bIns="0" rtlCol="0" anchor="ctr"/>
+          <a:lstStyle/>
+          <a:p>
+            <a:pPr algn="ctr" indent="0" marL="0">
               <a:buNone/>
             </a:pPr>
             <a:r>
@@ -9038,6 +9070,10 @@
           </a:solidFill>
           <a:ln/>
         </p:spPr>
+        <p:txBody>
+          <a:bodyPr/>
+          <a:p/>
+        </p:txBody>
       </p:sp>
       <p:sp>
         <p:nvSpPr>
@@ -9086,8 +9122,8 @@
         </p:nvSpPr>
         <p:spPr>
           <a:xfrm>
-            <a:off x="4045306" y="3950208"/>
-            <a:ext cx="1711757" cy="283464"/>
+            <a:off x="2697480" y="3950208"/>
+            <a:ext cx="1143000" cy="283464"/>
           </a:xfrm>
           <a:prstGeom prst="rect">
             <a:avLst/>
@@ -9125,20 +9161,20 @@
         </p:nvSpPr>
         <p:spPr>
           <a:xfrm>
-            <a:off x="5757062" y="3950208"/>
-            <a:ext cx="1978762" cy="283464"/>
-          </a:xfrm>
-          <a:prstGeom prst="rect">
-            <a:avLst/>
-          </a:prstGeom>
-          <a:noFill/>
-          <a:ln/>
-        </p:spPr>
-        <p:txBody>
-          <a:bodyPr wrap="square" lIns="0" tIns="0" rIns="0" bIns="0" rtlCol="0" anchor="ctr"/>
-          <a:lstStyle/>
-          <a:p>
-            <a:pPr algn="r" indent="0" marL="0">
+            <a:off x="6355080" y="3950208"/>
+            <a:ext cx="1417320" cy="283464"/>
+          </a:xfrm>
+          <a:prstGeom prst="rect">
+            <a:avLst/>
+          </a:prstGeom>
+          <a:noFill/>
+          <a:ln/>
+        </p:spPr>
+        <p:txBody>
+          <a:bodyPr wrap="square" lIns="0" tIns="0" rIns="0" bIns="0" rtlCol="0" anchor="ctr"/>
+          <a:lstStyle/>
+          <a:p>
+            <a:pPr algn="ctr" indent="0" marL="0">
               <a:buNone/>
             </a:pPr>
             <a:r>
@@ -9175,6 +9211,10 @@
           </a:solidFill>
           <a:ln/>
         </p:spPr>
+        <p:txBody>
+          <a:bodyPr/>
+          <a:p/>
+        </p:txBody>
       </p:sp>
       <p:sp>
         <p:nvSpPr>
@@ -9223,8 +9263,8 @@
         </p:nvSpPr>
         <p:spPr>
           <a:xfrm>
-            <a:off x="4045306" y="4233672"/>
-            <a:ext cx="1711757" cy="283464"/>
+            <a:off x="2697480" y="4233672"/>
+            <a:ext cx="1143000" cy="283464"/>
           </a:xfrm>
           <a:prstGeom prst="rect">
             <a:avLst/>
@@ -9262,20 +9302,20 @@
         </p:nvSpPr>
         <p:spPr>
           <a:xfrm>
-            <a:off x="5757062" y="4233672"/>
-            <a:ext cx="1978762" cy="283464"/>
-          </a:xfrm>
-          <a:prstGeom prst="rect">
-            <a:avLst/>
-          </a:prstGeom>
-          <a:noFill/>
-          <a:ln/>
-        </p:spPr>
-        <p:txBody>
-          <a:bodyPr wrap="square" lIns="0" tIns="0" rIns="0" bIns="0" rtlCol="0" anchor="ctr"/>
-          <a:lstStyle/>
-          <a:p>
-            <a:pPr algn="r" indent="0" marL="0">
+            <a:off x="6355080" y="4233672"/>
+            <a:ext cx="1417320" cy="283464"/>
+          </a:xfrm>
+          <a:prstGeom prst="rect">
+            <a:avLst/>
+          </a:prstGeom>
+          <a:noFill/>
+          <a:ln/>
+        </p:spPr>
+        <p:txBody>
+          <a:bodyPr wrap="square" lIns="0" tIns="0" rIns="0" bIns="0" rtlCol="0" anchor="ctr"/>
+          <a:lstStyle/>
+          <a:p>
+            <a:pPr algn="ctr" indent="0" marL="0">
               <a:buNone/>
             </a:pPr>
             <a:r>
@@ -9301,24 +9341,24 @@
         </p:nvSpPr>
         <p:spPr>
           <a:xfrm>
-            <a:off x="1280160" y="4581144"/>
-            <a:ext cx="6583680" cy="292608"/>
-          </a:xfrm>
-          <a:prstGeom prst="rect">
-            <a:avLst/>
-          </a:prstGeom>
-          <a:noFill/>
-          <a:ln/>
-        </p:spPr>
-        <p:txBody>
-          <a:bodyPr wrap="square" lIns="0" tIns="0" rIns="0" bIns="0" rtlCol="0" anchor="ctr"/>
-          <a:lstStyle/>
-          <a:p>
-            <a:pPr algn="ctr" indent="0" marL="0">
-              <a:buNone/>
-            </a:pPr>
-            <a:r>
-              <a:rPr lang="en-US" sz="850" i="1" dirty="0">
+            <a:off x="1280160" y="4846320"/>
+            <a:ext cx="6583680" cy="219456"/>
+          </a:xfrm>
+          <a:prstGeom prst="rect">
+            <a:avLst/>
+          </a:prstGeom>
+          <a:noFill/>
+          <a:ln/>
+        </p:spPr>
+        <p:txBody>
+          <a:bodyPr wrap="square" lIns="0" tIns="0" rIns="0" bIns="0" rtlCol="0" anchor="ctr"/>
+          <a:lstStyle/>
+          <a:p>
+            <a:pPr algn="ctr" indent="0" marL="0">
+              <a:buNone/>
+            </a:pPr>
+            <a:r>
+              <a:rPr lang="en-US" sz="750" i="1" dirty="0">
                 <a:solidFill>
                   <a:srgbClr val="8C9AC0"/>
                 </a:solidFill>
@@ -9329,6 +9369,747 @@
               <a:t>Completion bonus is exact (16 × tier price × 20%). Direct and uni-level earnings depend on your own activity — illustration, not a guarantee of income.</a:t>
             </a:r>
             <a:endParaRPr lang="en-US" sz="850" dirty="0"/>
+          </a:p>
+        </p:txBody>
+      </p:sp>
+      <p:sp>
+        <p:nvSpPr>
+          <p:cNvPr id="9" name="Text 7"/>
+          <p:cNvSpPr/>
+          <p:nvPr/>
+        </p:nvSpPr>
+        <p:spPr>
+          <a:xfrm>
+            <a:off x="3858768" y="1938528"/>
+            <a:ext cx="1143000" cy="310896"/>
+          </a:xfrm>
+          <a:prstGeom prst="rect">
+            <a:avLst/>
+          </a:prstGeom>
+          <a:noFill/>
+          <a:ln/>
+        </p:spPr>
+        <p:txBody>
+          <a:bodyPr wrap="square" lIns="0" tIns="0" rIns="0" bIns="0" rtlCol="0" anchor="ctr"/>
+          <a:lstStyle/>
+          <a:p>
+            <a:pPr algn="ctr" indent="0" marL="0">
+              <a:buNone/>
+            </a:pPr>
+            <a:r>
+              <a:rPr lang="en-US" sz="800" b="1" spc="100" kern="0" dirty="0">
+                <a:solidFill>
+                  <a:srgbClr val="22D3EE"/>
+                </a:solidFill>
+                <a:latin typeface="Arial" pitchFamily="34" charset="0"/>
+                <a:ea typeface="Arial" pitchFamily="34" charset="-122"/>
+                <a:cs typeface="Arial" pitchFamily="34" charset="-120"/>
+              </a:rPr>
+              <a:t>DIRECT (30%)</a:t>
+            </a:r>
+            <a:endParaRPr lang="en-US" sz="1000" dirty="0"/>
+          </a:p>
+        </p:txBody>
+      </p:sp>
+      <p:sp>
+        <p:nvSpPr>
+          <p:cNvPr id="13" name="Text 11"/>
+          <p:cNvSpPr/>
+          <p:nvPr/>
+        </p:nvSpPr>
+        <p:spPr>
+          <a:xfrm>
+            <a:off x="3858768" y="2249424"/>
+            <a:ext cx="1143000" cy="283464"/>
+          </a:xfrm>
+          <a:prstGeom prst="rect">
+            <a:avLst/>
+          </a:prstGeom>
+          <a:noFill/>
+          <a:ln/>
+        </p:spPr>
+        <p:txBody>
+          <a:bodyPr wrap="square" lIns="0" tIns="0" rIns="0" bIns="0" rtlCol="0" anchor="ctr"/>
+          <a:lstStyle/>
+          <a:p>
+            <a:pPr algn="ctr" indent="0" marL="0">
+              <a:buNone/>
+            </a:pPr>
+            <a:r>
+              <a:rPr lang="en-US" sz="1150" dirty="0">
+                <a:solidFill>
+                  <a:srgbClr val="CFE0F5"/>
+                </a:solidFill>
+                <a:latin typeface="Arial" pitchFamily="34" charset="0"/>
+                <a:ea typeface="Arial" pitchFamily="34" charset="-122"/>
+                <a:cs typeface="Arial" pitchFamily="34" charset="-120"/>
+              </a:rPr>
+              <a:t>$6</a:t>
+            </a:r>
+            <a:endParaRPr lang="en-US" sz="1150" dirty="0"/>
+          </a:p>
+        </p:txBody>
+      </p:sp>
+      <p:sp>
+        <p:nvSpPr>
+          <p:cNvPr id="17" name="Text 15"/>
+          <p:cNvSpPr/>
+          <p:nvPr/>
+        </p:nvSpPr>
+        <p:spPr>
+          <a:xfrm>
+            <a:off x="3858768" y="2532888"/>
+            <a:ext cx="1143000" cy="283464"/>
+          </a:xfrm>
+          <a:prstGeom prst="rect">
+            <a:avLst/>
+          </a:prstGeom>
+          <a:noFill/>
+          <a:ln/>
+        </p:spPr>
+        <p:txBody>
+          <a:bodyPr wrap="square" lIns="0" tIns="0" rIns="0" bIns="0" rtlCol="0" anchor="ctr"/>
+          <a:lstStyle/>
+          <a:p>
+            <a:pPr algn="ctr" indent="0" marL="0">
+              <a:buNone/>
+            </a:pPr>
+            <a:r>
+              <a:rPr lang="en-US" sz="1150" dirty="0">
+                <a:solidFill>
+                  <a:srgbClr val="CFE0F5"/>
+                </a:solidFill>
+                <a:latin typeface="Arial" pitchFamily="34" charset="0"/>
+                <a:ea typeface="Arial" pitchFamily="34" charset="-122"/>
+                <a:cs typeface="Arial" pitchFamily="34" charset="-120"/>
+              </a:rPr>
+              <a:t>$15</a:t>
+            </a:r>
+            <a:endParaRPr lang="en-US" sz="1150" dirty="0"/>
+          </a:p>
+        </p:txBody>
+      </p:sp>
+      <p:sp>
+        <p:nvSpPr>
+          <p:cNvPr id="21" name="Text 19"/>
+          <p:cNvSpPr/>
+          <p:nvPr/>
+        </p:nvSpPr>
+        <p:spPr>
+          <a:xfrm>
+            <a:off x="3858768" y="2816352"/>
+            <a:ext cx="1143000" cy="283464"/>
+          </a:xfrm>
+          <a:prstGeom prst="rect">
+            <a:avLst/>
+          </a:prstGeom>
+          <a:noFill/>
+          <a:ln/>
+        </p:spPr>
+        <p:txBody>
+          <a:bodyPr wrap="square" lIns="0" tIns="0" rIns="0" bIns="0" rtlCol="0" anchor="ctr"/>
+          <a:lstStyle/>
+          <a:p>
+            <a:pPr algn="ctr" indent="0" marL="0">
+              <a:buNone/>
+            </a:pPr>
+            <a:r>
+              <a:rPr lang="en-US" sz="1150" dirty="0">
+                <a:solidFill>
+                  <a:srgbClr val="CFE0F5"/>
+                </a:solidFill>
+                <a:latin typeface="Arial" pitchFamily="34" charset="0"/>
+                <a:ea typeface="Arial" pitchFamily="34" charset="-122"/>
+                <a:cs typeface="Arial" pitchFamily="34" charset="-120"/>
+              </a:rPr>
+              <a:t>$30</a:t>
+            </a:r>
+            <a:endParaRPr lang="en-US" sz="1150" dirty="0"/>
+          </a:p>
+        </p:txBody>
+      </p:sp>
+      <p:sp>
+        <p:nvSpPr>
+          <p:cNvPr id="25" name="Text 23"/>
+          <p:cNvSpPr/>
+          <p:nvPr/>
+        </p:nvSpPr>
+        <p:spPr>
+          <a:xfrm>
+            <a:off x="3858768" y="3099816"/>
+            <a:ext cx="1143000" cy="283464"/>
+          </a:xfrm>
+          <a:prstGeom prst="rect">
+            <a:avLst/>
+          </a:prstGeom>
+          <a:noFill/>
+          <a:ln/>
+        </p:spPr>
+        <p:txBody>
+          <a:bodyPr wrap="square" lIns="0" tIns="0" rIns="0" bIns="0" rtlCol="0" anchor="ctr"/>
+          <a:lstStyle/>
+          <a:p>
+            <a:pPr algn="ctr" indent="0" marL="0">
+              <a:buNone/>
+            </a:pPr>
+            <a:r>
+              <a:rPr lang="en-US" sz="1150" dirty="0">
+                <a:solidFill>
+                  <a:srgbClr val="CFE0F5"/>
+                </a:solidFill>
+                <a:latin typeface="Arial" pitchFamily="34" charset="0"/>
+                <a:ea typeface="Arial" pitchFamily="34" charset="-122"/>
+                <a:cs typeface="Arial" pitchFamily="34" charset="-120"/>
+              </a:rPr>
+              <a:t>$60</a:t>
+            </a:r>
+            <a:endParaRPr lang="en-US" sz="1150" dirty="0"/>
+          </a:p>
+        </p:txBody>
+      </p:sp>
+      <p:sp>
+        <p:nvSpPr>
+          <p:cNvPr id="29" name="Text 27"/>
+          <p:cNvSpPr/>
+          <p:nvPr/>
+        </p:nvSpPr>
+        <p:spPr>
+          <a:xfrm>
+            <a:off x="3858768" y="3383280"/>
+            <a:ext cx="1143000" cy="283464"/>
+          </a:xfrm>
+          <a:prstGeom prst="rect">
+            <a:avLst/>
+          </a:prstGeom>
+          <a:noFill/>
+          <a:ln/>
+        </p:spPr>
+        <p:txBody>
+          <a:bodyPr wrap="square" lIns="0" tIns="0" rIns="0" bIns="0" rtlCol="0" anchor="ctr"/>
+          <a:lstStyle/>
+          <a:p>
+            <a:pPr algn="ctr" indent="0" marL="0">
+              <a:buNone/>
+            </a:pPr>
+            <a:r>
+              <a:rPr lang="en-US" sz="1150" dirty="0">
+                <a:solidFill>
+                  <a:srgbClr val="CFE0F5"/>
+                </a:solidFill>
+                <a:latin typeface="Arial" pitchFamily="34" charset="0"/>
+                <a:ea typeface="Arial" pitchFamily="34" charset="-122"/>
+                <a:cs typeface="Arial" pitchFamily="34" charset="-120"/>
+              </a:rPr>
+              <a:t>$120</a:t>
+            </a:r>
+            <a:endParaRPr lang="en-US" sz="1150" dirty="0"/>
+          </a:p>
+        </p:txBody>
+      </p:sp>
+      <p:sp>
+        <p:nvSpPr>
+          <p:cNvPr id="33" name="Text 31"/>
+          <p:cNvSpPr/>
+          <p:nvPr/>
+        </p:nvSpPr>
+        <p:spPr>
+          <a:xfrm>
+            <a:off x="3858768" y="3666744"/>
+            <a:ext cx="1143000" cy="283464"/>
+          </a:xfrm>
+          <a:prstGeom prst="rect">
+            <a:avLst/>
+          </a:prstGeom>
+          <a:noFill/>
+          <a:ln/>
+        </p:spPr>
+        <p:txBody>
+          <a:bodyPr wrap="square" lIns="0" tIns="0" rIns="0" bIns="0" rtlCol="0" anchor="ctr"/>
+          <a:lstStyle/>
+          <a:p>
+            <a:pPr algn="ctr" indent="0" marL="0">
+              <a:buNone/>
+            </a:pPr>
+            <a:r>
+              <a:rPr lang="en-US" sz="1150" dirty="0">
+                <a:solidFill>
+                  <a:srgbClr val="CFE0F5"/>
+                </a:solidFill>
+                <a:latin typeface="Arial" pitchFamily="34" charset="0"/>
+                <a:ea typeface="Arial" pitchFamily="34" charset="-122"/>
+                <a:cs typeface="Arial" pitchFamily="34" charset="-120"/>
+              </a:rPr>
+              <a:t>$180</a:t>
+            </a:r>
+            <a:endParaRPr lang="en-US" sz="1150" dirty="0"/>
+          </a:p>
+        </p:txBody>
+      </p:sp>
+      <p:sp>
+        <p:nvSpPr>
+          <p:cNvPr id="37" name="Text 35"/>
+          <p:cNvSpPr/>
+          <p:nvPr/>
+        </p:nvSpPr>
+        <p:spPr>
+          <a:xfrm>
+            <a:off x="3858768" y="3950208"/>
+            <a:ext cx="1143000" cy="283464"/>
+          </a:xfrm>
+          <a:prstGeom prst="rect">
+            <a:avLst/>
+          </a:prstGeom>
+          <a:noFill/>
+          <a:ln/>
+        </p:spPr>
+        <p:txBody>
+          <a:bodyPr wrap="square" lIns="0" tIns="0" rIns="0" bIns="0" rtlCol="0" anchor="ctr"/>
+          <a:lstStyle/>
+          <a:p>
+            <a:pPr algn="ctr" indent="0" marL="0">
+              <a:buNone/>
+            </a:pPr>
+            <a:r>
+              <a:rPr lang="en-US" sz="1150" dirty="0">
+                <a:solidFill>
+                  <a:srgbClr val="CFE0F5"/>
+                </a:solidFill>
+                <a:latin typeface="Arial" pitchFamily="34" charset="0"/>
+                <a:ea typeface="Arial" pitchFamily="34" charset="-122"/>
+                <a:cs typeface="Arial" pitchFamily="34" charset="-120"/>
+              </a:rPr>
+              <a:t>$240</a:t>
+            </a:r>
+            <a:endParaRPr lang="en-US" sz="1150" dirty="0"/>
+          </a:p>
+        </p:txBody>
+      </p:sp>
+      <p:sp>
+        <p:nvSpPr>
+          <p:cNvPr id="41" name="Text 39"/>
+          <p:cNvSpPr/>
+          <p:nvPr/>
+        </p:nvSpPr>
+        <p:spPr>
+          <a:xfrm>
+            <a:off x="3858768" y="4233672"/>
+            <a:ext cx="1143000" cy="283464"/>
+          </a:xfrm>
+          <a:prstGeom prst="rect">
+            <a:avLst/>
+          </a:prstGeom>
+          <a:noFill/>
+          <a:ln/>
+        </p:spPr>
+        <p:txBody>
+          <a:bodyPr wrap="square" lIns="0" tIns="0" rIns="0" bIns="0" rtlCol="0" anchor="ctr"/>
+          <a:lstStyle/>
+          <a:p>
+            <a:pPr algn="ctr" indent="0" marL="0">
+              <a:buNone/>
+            </a:pPr>
+            <a:r>
+              <a:rPr lang="en-US" sz="1150" dirty="0">
+                <a:solidFill>
+                  <a:srgbClr val="CFE0F5"/>
+                </a:solidFill>
+                <a:latin typeface="Arial" pitchFamily="34" charset="0"/>
+                <a:ea typeface="Arial" pitchFamily="34" charset="-122"/>
+                <a:cs typeface="Arial" pitchFamily="34" charset="-120"/>
+              </a:rPr>
+              <a:t>$300</a:t>
+            </a:r>
+            <a:endParaRPr lang="en-US" sz="1150" dirty="0"/>
+          </a:p>
+        </p:txBody>
+      </p:sp>
+      <p:sp>
+        <p:nvSpPr>
+          <p:cNvPr id="9" name="Text 7"/>
+          <p:cNvSpPr/>
+          <p:nvPr/>
+        </p:nvSpPr>
+        <p:spPr>
+          <a:xfrm>
+            <a:off x="5020056" y="1938528"/>
+            <a:ext cx="1298448" cy="310896"/>
+          </a:xfrm>
+          <a:prstGeom prst="rect">
+            <a:avLst/>
+          </a:prstGeom>
+          <a:noFill/>
+          <a:ln/>
+        </p:spPr>
+        <p:txBody>
+          <a:bodyPr wrap="square" lIns="0" tIns="0" rIns="0" bIns="0" rtlCol="0" anchor="ctr"/>
+          <a:lstStyle/>
+          <a:p>
+            <a:pPr algn="ctr" indent="0" marL="0">
+              <a:buNone/>
+            </a:pPr>
+            <a:r>
+              <a:rPr lang="en-US" sz="800" b="1" spc="100" kern="0" dirty="0">
+                <a:solidFill>
+                  <a:srgbClr val="22D3EE"/>
+                </a:solidFill>
+                <a:latin typeface="Arial" pitchFamily="34" charset="0"/>
+                <a:ea typeface="Arial" pitchFamily="34" charset="-122"/>
+                <a:cs typeface="Arial" pitchFamily="34" charset="-120"/>
+              </a:rPr>
+              <a:t>UNI-LEVEL (6.25%)</a:t>
+            </a:r>
+            <a:endParaRPr lang="en-US" sz="1000" dirty="0"/>
+          </a:p>
+        </p:txBody>
+      </p:sp>
+      <p:sp>
+        <p:nvSpPr>
+          <p:cNvPr id="13" name="Text 11"/>
+          <p:cNvSpPr/>
+          <p:nvPr/>
+        </p:nvSpPr>
+        <p:spPr>
+          <a:xfrm>
+            <a:off x="5020056" y="2249424"/>
+            <a:ext cx="1298448" cy="283464"/>
+          </a:xfrm>
+          <a:prstGeom prst="rect">
+            <a:avLst/>
+          </a:prstGeom>
+          <a:noFill/>
+          <a:ln/>
+        </p:spPr>
+        <p:txBody>
+          <a:bodyPr wrap="square" lIns="0" tIns="0" rIns="0" bIns="0" rtlCol="0" anchor="ctr"/>
+          <a:lstStyle/>
+          <a:p>
+            <a:pPr algn="ctr" indent="0" marL="0">
+              <a:buNone/>
+            </a:pPr>
+            <a:r>
+              <a:rPr lang="en-US" sz="1150" dirty="0">
+                <a:solidFill>
+                  <a:srgbClr val="CFE0F5"/>
+                </a:solidFill>
+                <a:latin typeface="Arial" pitchFamily="34" charset="0"/>
+                <a:ea typeface="Arial" pitchFamily="34" charset="-122"/>
+                <a:cs typeface="Arial" pitchFamily="34" charset="-120"/>
+              </a:rPr>
+              <a:t>$1.25</a:t>
+            </a:r>
+            <a:endParaRPr lang="en-US" sz="1150" dirty="0"/>
+          </a:p>
+        </p:txBody>
+      </p:sp>
+      <p:sp>
+        <p:nvSpPr>
+          <p:cNvPr id="17" name="Text 15"/>
+          <p:cNvSpPr/>
+          <p:nvPr/>
+        </p:nvSpPr>
+        <p:spPr>
+          <a:xfrm>
+            <a:off x="5020056" y="2532888"/>
+            <a:ext cx="1298448" cy="283464"/>
+          </a:xfrm>
+          <a:prstGeom prst="rect">
+            <a:avLst/>
+          </a:prstGeom>
+          <a:noFill/>
+          <a:ln/>
+        </p:spPr>
+        <p:txBody>
+          <a:bodyPr wrap="square" lIns="0" tIns="0" rIns="0" bIns="0" rtlCol="0" anchor="ctr"/>
+          <a:lstStyle/>
+          <a:p>
+            <a:pPr algn="ctr" indent="0" marL="0">
+              <a:buNone/>
+            </a:pPr>
+            <a:r>
+              <a:rPr lang="en-US" sz="1150" dirty="0">
+                <a:solidFill>
+                  <a:srgbClr val="CFE0F5"/>
+                </a:solidFill>
+                <a:latin typeface="Arial" pitchFamily="34" charset="0"/>
+                <a:ea typeface="Arial" pitchFamily="34" charset="-122"/>
+                <a:cs typeface="Arial" pitchFamily="34" charset="-120"/>
+              </a:rPr>
+              <a:t>$3.13</a:t>
+            </a:r>
+            <a:endParaRPr lang="en-US" sz="1150" dirty="0"/>
+          </a:p>
+        </p:txBody>
+      </p:sp>
+      <p:sp>
+        <p:nvSpPr>
+          <p:cNvPr id="21" name="Text 19"/>
+          <p:cNvSpPr/>
+          <p:nvPr/>
+        </p:nvSpPr>
+        <p:spPr>
+          <a:xfrm>
+            <a:off x="5020056" y="2816352"/>
+            <a:ext cx="1298448" cy="283464"/>
+          </a:xfrm>
+          <a:prstGeom prst="rect">
+            <a:avLst/>
+          </a:prstGeom>
+          <a:noFill/>
+          <a:ln/>
+        </p:spPr>
+        <p:txBody>
+          <a:bodyPr wrap="square" lIns="0" tIns="0" rIns="0" bIns="0" rtlCol="0" anchor="ctr"/>
+          <a:lstStyle/>
+          <a:p>
+            <a:pPr algn="ctr" indent="0" marL="0">
+              <a:buNone/>
+            </a:pPr>
+            <a:r>
+              <a:rPr lang="en-US" sz="1150" dirty="0">
+                <a:solidFill>
+                  <a:srgbClr val="CFE0F5"/>
+                </a:solidFill>
+                <a:latin typeface="Arial" pitchFamily="34" charset="0"/>
+                <a:ea typeface="Arial" pitchFamily="34" charset="-122"/>
+                <a:cs typeface="Arial" pitchFamily="34" charset="-120"/>
+              </a:rPr>
+              <a:t>$6.25</a:t>
+            </a:r>
+            <a:endParaRPr lang="en-US" sz="1150" dirty="0"/>
+          </a:p>
+        </p:txBody>
+      </p:sp>
+      <p:sp>
+        <p:nvSpPr>
+          <p:cNvPr id="25" name="Text 23"/>
+          <p:cNvSpPr/>
+          <p:nvPr/>
+        </p:nvSpPr>
+        <p:spPr>
+          <a:xfrm>
+            <a:off x="5020056" y="3099816"/>
+            <a:ext cx="1298448" cy="283464"/>
+          </a:xfrm>
+          <a:prstGeom prst="rect">
+            <a:avLst/>
+          </a:prstGeom>
+          <a:noFill/>
+          <a:ln/>
+        </p:spPr>
+        <p:txBody>
+          <a:bodyPr wrap="square" lIns="0" tIns="0" rIns="0" bIns="0" rtlCol="0" anchor="ctr"/>
+          <a:lstStyle/>
+          <a:p>
+            <a:pPr algn="ctr" indent="0" marL="0">
+              <a:buNone/>
+            </a:pPr>
+            <a:r>
+              <a:rPr lang="en-US" sz="1150" dirty="0">
+                <a:solidFill>
+                  <a:srgbClr val="CFE0F5"/>
+                </a:solidFill>
+                <a:latin typeface="Arial" pitchFamily="34" charset="0"/>
+                <a:ea typeface="Arial" pitchFamily="34" charset="-122"/>
+                <a:cs typeface="Arial" pitchFamily="34" charset="-120"/>
+              </a:rPr>
+              <a:t>$12.50</a:t>
+            </a:r>
+            <a:endParaRPr lang="en-US" sz="1150" dirty="0"/>
+          </a:p>
+        </p:txBody>
+      </p:sp>
+      <p:sp>
+        <p:nvSpPr>
+          <p:cNvPr id="29" name="Text 27"/>
+          <p:cNvSpPr/>
+          <p:nvPr/>
+        </p:nvSpPr>
+        <p:spPr>
+          <a:xfrm>
+            <a:off x="5020056" y="3383280"/>
+            <a:ext cx="1298448" cy="283464"/>
+          </a:xfrm>
+          <a:prstGeom prst="rect">
+            <a:avLst/>
+          </a:prstGeom>
+          <a:noFill/>
+          <a:ln/>
+        </p:spPr>
+        <p:txBody>
+          <a:bodyPr wrap="square" lIns="0" tIns="0" rIns="0" bIns="0" rtlCol="0" anchor="ctr"/>
+          <a:lstStyle/>
+          <a:p>
+            <a:pPr algn="ctr" indent="0" marL="0">
+              <a:buNone/>
+            </a:pPr>
+            <a:r>
+              <a:rPr lang="en-US" sz="1150" dirty="0">
+                <a:solidFill>
+                  <a:srgbClr val="CFE0F5"/>
+                </a:solidFill>
+                <a:latin typeface="Arial" pitchFamily="34" charset="0"/>
+                <a:ea typeface="Arial" pitchFamily="34" charset="-122"/>
+                <a:cs typeface="Arial" pitchFamily="34" charset="-120"/>
+              </a:rPr>
+              <a:t>$25.00</a:t>
+            </a:r>
+            <a:endParaRPr lang="en-US" sz="1150" dirty="0"/>
+          </a:p>
+        </p:txBody>
+      </p:sp>
+      <p:sp>
+        <p:nvSpPr>
+          <p:cNvPr id="33" name="Text 31"/>
+          <p:cNvSpPr/>
+          <p:nvPr/>
+        </p:nvSpPr>
+        <p:spPr>
+          <a:xfrm>
+            <a:off x="5020056" y="3666744"/>
+            <a:ext cx="1298448" cy="283464"/>
+          </a:xfrm>
+          <a:prstGeom prst="rect">
+            <a:avLst/>
+          </a:prstGeom>
+          <a:noFill/>
+          <a:ln/>
+        </p:spPr>
+        <p:txBody>
+          <a:bodyPr wrap="square" lIns="0" tIns="0" rIns="0" bIns="0" rtlCol="0" anchor="ctr"/>
+          <a:lstStyle/>
+          <a:p>
+            <a:pPr algn="ctr" indent="0" marL="0">
+              <a:buNone/>
+            </a:pPr>
+            <a:r>
+              <a:rPr lang="en-US" sz="1150" dirty="0">
+                <a:solidFill>
+                  <a:srgbClr val="CFE0F5"/>
+                </a:solidFill>
+                <a:latin typeface="Arial" pitchFamily="34" charset="0"/>
+                <a:ea typeface="Arial" pitchFamily="34" charset="-122"/>
+                <a:cs typeface="Arial" pitchFamily="34" charset="-120"/>
+              </a:rPr>
+              <a:t>$37.50</a:t>
+            </a:r>
+            <a:endParaRPr lang="en-US" sz="1150" dirty="0"/>
+          </a:p>
+        </p:txBody>
+      </p:sp>
+      <p:sp>
+        <p:nvSpPr>
+          <p:cNvPr id="37" name="Text 35"/>
+          <p:cNvSpPr/>
+          <p:nvPr/>
+        </p:nvSpPr>
+        <p:spPr>
+          <a:xfrm>
+            <a:off x="5020056" y="3950208"/>
+            <a:ext cx="1298448" cy="283464"/>
+          </a:xfrm>
+          <a:prstGeom prst="rect">
+            <a:avLst/>
+          </a:prstGeom>
+          <a:noFill/>
+          <a:ln/>
+        </p:spPr>
+        <p:txBody>
+          <a:bodyPr wrap="square" lIns="0" tIns="0" rIns="0" bIns="0" rtlCol="0" anchor="ctr"/>
+          <a:lstStyle/>
+          <a:p>
+            <a:pPr algn="ctr" indent="0" marL="0">
+              <a:buNone/>
+            </a:pPr>
+            <a:r>
+              <a:rPr lang="en-US" sz="1150" dirty="0">
+                <a:solidFill>
+                  <a:srgbClr val="CFE0F5"/>
+                </a:solidFill>
+                <a:latin typeface="Arial" pitchFamily="34" charset="0"/>
+                <a:ea typeface="Arial" pitchFamily="34" charset="-122"/>
+                <a:cs typeface="Arial" pitchFamily="34" charset="-120"/>
+              </a:rPr>
+              <a:t>$50.00</a:t>
+            </a:r>
+            <a:endParaRPr lang="en-US" sz="1150" dirty="0"/>
+          </a:p>
+        </p:txBody>
+      </p:sp>
+      <p:sp>
+        <p:nvSpPr>
+          <p:cNvPr id="41" name="Text 39"/>
+          <p:cNvSpPr/>
+          <p:nvPr/>
+        </p:nvSpPr>
+        <p:spPr>
+          <a:xfrm>
+            <a:off x="5020056" y="4233672"/>
+            <a:ext cx="1298448" cy="283464"/>
+          </a:xfrm>
+          <a:prstGeom prst="rect">
+            <a:avLst/>
+          </a:prstGeom>
+          <a:noFill/>
+          <a:ln/>
+        </p:spPr>
+        <p:txBody>
+          <a:bodyPr wrap="square" lIns="0" tIns="0" rIns="0" bIns="0" rtlCol="0" anchor="ctr"/>
+          <a:lstStyle/>
+          <a:p>
+            <a:pPr algn="ctr" indent="0" marL="0">
+              <a:buNone/>
+            </a:pPr>
+            <a:r>
+              <a:rPr lang="en-US" sz="1150" dirty="0">
+                <a:solidFill>
+                  <a:srgbClr val="CFE0F5"/>
+                </a:solidFill>
+                <a:latin typeface="Arial" pitchFamily="34" charset="0"/>
+                <a:ea typeface="Arial" pitchFamily="34" charset="-122"/>
+                <a:cs typeface="Arial" pitchFamily="34" charset="-120"/>
+              </a:rPr>
+              <a:t>$62.50</a:t>
+            </a:r>
+            <a:endParaRPr lang="en-US" sz="1150" dirty="0"/>
+          </a:p>
+        </p:txBody>
+      </p:sp>
+      <p:sp>
+        <p:nvSpPr>
+          <p:cNvPr id="10" name="Text 8"/>
+          <p:cNvSpPr/>
+          <p:nvPr/>
+        </p:nvSpPr>
+        <p:spPr>
+          <a:xfrm>
+            <a:off x="1389888" y="4562856"/>
+            <a:ext cx="6364224" cy="237744"/>
+          </a:xfrm>
+          <a:prstGeom prst="rect">
+            <a:avLst/>
+          </a:prstGeom>
+          <a:noFill/>
+          <a:ln/>
+        </p:spPr>
+        <p:txBody>
+          <a:bodyPr wrap="square" lIns="0" tIns="0" rIns="0" bIns="0" rtlCol="0" anchor="ctr"/>
+          <a:lstStyle/>
+          <a:p>
+            <a:pPr algn="l" indent="0" marL="0">
+              <a:buNone/>
+            </a:pPr>
+            <a:r>
+              <a:rPr lang="en-US" sz="1050" b="1" spc="100" kern="0" dirty="0">
+                <a:solidFill>
+                  <a:srgbClr val="22D3EE"/>
+                </a:solidFill>
+                <a:latin typeface="Arial" pitchFamily="34" charset="0"/>
+                <a:ea typeface="Arial" pitchFamily="34" charset="-122"/>
+                <a:cs typeface="Arial" pitchFamily="34" charset="-120"/>
+              </a:rPr>
+              <a:t>Uni-level shown per position — earned on every position, 8 levels deep</a:t>
+            </a:r>
+            <a:endParaRPr lang="en-US" sz="1000" dirty="0"/>
           </a:p>
         </p:txBody>
       </p:sp>

</xml_diff>